<commit_message>
docs(deck): 태스크 수치 정정 38/52 → 48/52 (구현 완료)
집계했더니 이전 「38 / 52 태스크 구현·배포 완료」는 틀린 수치였다. 38은 우연히 «review 상태만»
센 값과 정확히 일치하고, done이 빠져 있었다.

docs/Tasks.md 52개 전수 집계 (마지막 칸을 상태로 읽음 — 표 모양이 두 가지라 열 위치로는 안 된다):

  review   38   구현·테스트 완료, 실확장 확인 대기
  done     10   실확장 확인까지 완료 (8건 + 다른 표기 2건 S26·S27)
  진행 중    1   S22 GitHub 연동 — 코어·실 API 확인 완료, UI만 남음
  기능 OFF   1   S25 결정 요약 — 구현해 두고 의도적으로 껐다(FEATURES.decisionSummary=false)
  todo      2   S28 시연 촬영 · S29 피치덱+제출 (기능이 아니라 마감 작업)

→ 「구현 완료」는 review + done = 48. 라벨도 「구현·배포 완료」에서 「구현 완료」로 바꿨다.
  일부 review는 빌드까지만 된 것이라 「배포」가 과한 표현이었다.
→ 부제로 「그중 10건은 실확장 확인까지」를 넣었다. 숫자가 커지면서 «동시에 더 정확해진다».
  덱의 원칙(「구현 완료, 검증 진행 중」)과도 정확히 맞는다 — 48은 구현, 10은 검증.

pptx는 「38 / 52」→「48 / 52」가 글자 수 동일, 라벨은 12자 → 9자라 레이아웃 위험이 없다.
부제 한 줄은 md·html에만 넣었다.

검증: zip 무결성 OK · 슬라이드 13장 · 세 파일 모두 48/52 · 옛 수치 잔존 0

Co-Authored-By: Claude Opus 5 <noreply@anthropic.com>
</commit_message>
<xml_diff>
--- a/docs/PitchDeck.pptx
+++ b/docs/PitchDeck.pptx
@@ -3700,7 +3700,7 @@
                 <a:ea typeface="Malgun Gothic" pitchFamily="34" charset="-122"/>
                 <a:cs typeface="Malgun Gothic" pitchFamily="34" charset="-120"/>
               </a:rPr>
-              <a:t>38 / 52</a:t>
+              <a:t>48 / 52</a:t>
             </a:r>
             <a:endParaRPr lang="en-US" sz="4000" dirty="0"/>
           </a:p>
@@ -3742,7 +3742,7 @@
                 <a:ea typeface="Malgun Gothic" pitchFamily="34" charset="-122"/>
                 <a:cs typeface="Malgun Gothic" pitchFamily="34" charset="-120"/>
               </a:rPr>
-              <a:t>태스크 구현·배포 완료</a:t>
+              <a:t>태스크 구현 완료</a:t>
             </a:r>
             <a:endParaRPr lang="en-US" sz="1300" dirty="0"/>
           </a:p>

</xml_diff>